<commit_message>
Add CTD salinity and turbidity; take depth from the CTD
Join CTD casts to LISST casts after correcting the per-day clock offset.
Retrain and regenerate results, figures, write-up and slides.
</commit_message>
<xml_diff>
--- a/report/slides.pptx
+++ b/report/slides.pptx
@@ -3362,7 +3362,7 @@
                 </a:solidFill>
                 <a:latin typeface="Segoe UI"/>
               </a:rPr>
-              <a:t>On data the model has not seen, accuracy halves, then collapses across sites</a:t>
+              <a:t>On data the model has not seen, accuracy drops by a third, then collapses across sites</a:t>
             </a:r>
           </a:p>
         </p:txBody>
@@ -3473,7 +3473,7 @@
                 </a:solidFill>
                 <a:latin typeface="Segoe UI"/>
               </a:rPr>
-              <a:t> Random Forest drops from 0.84 to 0.41 for d50 and from 0.78 to 0.54 for σ.</a:t>
+              <a:t> Random Forest drops from 0.86 to 0.56 for d50 and from 0.82 to 0.58 for σ.</a:t>
             </a:r>
           </a:p>
           <a:p>
@@ -3498,7 +3498,7 @@
                 </a:solidFill>
                 <a:latin typeface="Segoe UI"/>
               </a:rPr>
-              <a:t> SVR: 0.52 / 0.58 on unseen casts, 0.46 / 0.47 on an unseen day.</a:t>
+              <a:t> SVR: 0.60 / 0.62 on unseen casts, 0.46 / 0.53 on an unseen day.</a:t>
             </a:r>
           </a:p>
           <a:p>
@@ -3652,7 +3652,7 @@
                 </a:solidFill>
                 <a:latin typeface="Segoe UI"/>
               </a:rPr>
-              <a:t>Conclusions: about half the variation is predictable; the split decides the score</a:t>
+              <a:t>Conclusions: about 60 % of the variation is predictable; the split decides the score</a:t>
             </a:r>
           </a:p>
         </p:txBody>
@@ -3739,7 +3739,7 @@
                 </a:solidFill>
                 <a:latin typeface="Segoe UI"/>
               </a:rPr>
-              <a:t> Depth, tide stage, temperature and optical attenuation explain roughly half of the variation in d50 and σ on new casts.</a:t>
+              <a:t> Depth, tide stage, salinity, temperature and two optical measurements explain about 56–62 % of the variation in d50 and σ on new casts.</a:t>
             </a:r>
           </a:p>
           <a:p>
@@ -3764,7 +3764,7 @@
                 </a:solidFill>
                 <a:latin typeface="Segoe UI"/>
               </a:rPr>
-              <a:t> Its R² of 0.75 to 0.81 came from a random split of autocorrelated data. We reproduce it, then show it does not survive grouped testing. Its overfitting concern was justified.</a:t>
+              <a:t> Its R² of 0.75 to 0.81 came from a random split of autocorrelated data. We reproduce it, then show it falls under grouped testing. Its overfitting concern was justified.</a:t>
             </a:r>
           </a:p>
           <a:p>
@@ -3846,7 +3846,7 @@
                 </a:solidFill>
                 <a:latin typeface="Segoe UI"/>
               </a:rPr>
-              <a:t>•  No salinity or turbidity: the CTD files could not be downloaded</a:t>
+              <a:t>•  Salinity varied by only about 2 psu, so its effect is barely tested</a:t>
             </a:r>
           </a:p>
           <a:p>
@@ -3887,7 +3887,7 @@
                 </a:solidFill>
                 <a:latin typeface="Segoe UI"/>
               </a:rPr>
-              <a:t> Add the CTD and hydrodynamic data from the parent USGS release; train across more sites and seasons.</a:t>
+              <a:t> Add current and wave measurements from the release's hydrodynamic time series; train across more sites and seasons.</a:t>
             </a:r>
           </a:p>
         </p:txBody>
@@ -5296,7 +5296,7 @@
                 </a:solidFill>
                 <a:latin typeface="Segoe UI"/>
               </a:rPr>
-              <a:t>We used USGS casts from the same bay: two sites, four days, 94 files</a:t>
+              <a:t>We used USGS casts from the same bay: two sites, four days, 193 files</a:t>
             </a:r>
           </a:p>
         </p:txBody>
@@ -5433,7 +5433,7 @@
                 </a:solidFill>
                 <a:latin typeface="Segoe UI"/>
               </a:rPr>
-              <a:t> 36-class particle size spectrum, depth, temperature and beam attenuation, once per second.</a:t>
+              <a:t> LISST: 36-class particle size spectrum, temperature, beam attenuation. CTD: salinity, turbidity, depth.</a:t>
             </a:r>
           </a:p>
           <a:p>
@@ -5449,7 +5449,7 @@
                 </a:solidFill>
                 <a:latin typeface="Segoe UI"/>
               </a:rPr>
-              <a:t>•  Missing</a:t>
+              <a:t>•  Compared with the paper</a:t>
             </a:r>
             <a:r>
               <a:rPr sz="1600" b="0">
@@ -5458,7 +5458,7 @@
                 </a:solidFill>
                 <a:latin typeface="Segoe UI"/>
               </a:rPr>
-              <a:t> Salinity and turbidity (the CTD download links are dead); no chlorophyll or refractive index.</a:t>
+              <a:t> We have salinity and temperature; no chlorophyll, refractive index or wave and tidal velocity.</a:t>
             </a:r>
           </a:p>
         </p:txBody>
@@ -5479,8 +5479,8 @@
         </p:blipFill>
         <p:spPr>
           <a:xfrm>
-            <a:off x="1254155" y="3703320"/>
-            <a:ext cx="9653208" cy="2834640"/>
+            <a:off x="1250094" y="3703320"/>
+            <a:ext cx="9661330" cy="2834640"/>
           </a:xfrm>
           <a:prstGeom prst="rect">
             <a:avLst/>
@@ -5586,7 +5586,7 @@
                 </a:solidFill>
                 <a:latin typeface="Segoe UI"/>
               </a:rPr>
-              <a:t>Cleaning turned 45,639 raw samples into 3,731 reliable bursts</a:t>
+              <a:t>Cleaning turned 45,639 raw samples into 3,998 reliable bursts</a:t>
             </a:r>
           </a:p>
         </p:txBody>
@@ -5639,8 +5639,8 @@
           <p:nvPr/>
         </p:nvGraphicFramePr>
         <p:xfrm>
-          <a:off x="548640" y="1737360"/>
-          <a:ext cx="11064240" cy="1920240"/>
+          <a:off x="548640" y="1645920"/>
+          <a:ext cx="11064240" cy="2304288"/>
         </p:xfrm>
         <a:graphic>
           <a:graphicData uri="http://schemas.openxmlformats.org/drawingml/2006/table">
@@ -5660,7 +5660,7 @@
                     <a:lstStyle/>
                     <a:p>
                       <a:r>
-                        <a:rPr sz="1400" b="1">
+                        <a:rPr sz="1300" b="1">
                           <a:solidFill>
                             <a:srgbClr val="FFFFFF"/>
                           </a:solidFill>
@@ -5682,7 +5682,7 @@
                     <a:lstStyle/>
                     <a:p>
                       <a:r>
-                        <a:rPr sz="1400" b="1">
+                        <a:rPr sz="1300" b="1">
                           <a:solidFill>
                             <a:srgbClr val="FFFFFF"/>
                           </a:solidFill>
@@ -5704,7 +5704,7 @@
                     <a:lstStyle/>
                     <a:p>
                       <a:r>
-                        <a:rPr sz="1400" b="1">
+                        <a:rPr sz="1300" b="1">
                           <a:solidFill>
                             <a:srgbClr val="FFFFFF"/>
                           </a:solidFill>
@@ -5728,13 +5728,13 @@
                     <a:lstStyle/>
                     <a:p>
                       <a:r>
-                        <a:rPr sz="1400" b="0">
+                        <a:rPr sz="1300" b="0">
                           <a:solidFill>
                             <a:srgbClr val="0B0B0B"/>
                           </a:solidFill>
                           <a:latin typeface="Segoe UI"/>
                         </a:rPr>
-                        <a:t>Read 94 NetCDF files</a:t>
+                        <a:t>Read 193 NetCDF files</a:t>
                       </a:r>
                     </a:p>
                   </a:txBody>
@@ -5750,13 +5750,13 @@
                     <a:lstStyle/>
                     <a:p>
                       <a:r>
-                        <a:rPr sz="1400" b="0">
+                        <a:rPr sz="1300" b="0">
                           <a:solidFill>
                             <a:srgbClr val="0B0B0B"/>
                           </a:solidFill>
                           <a:latin typeface="Segoe UI"/>
                         </a:rPr>
-                        <a:t>Decode the EPIC time format; drop one file that duplicates another</a:t>
+                        <a:t>Decode the EPIC time format; drop one LISST file that duplicates another</a:t>
                       </a:r>
                     </a:p>
                   </a:txBody>
@@ -5772,7 +5772,7 @@
                     <a:lstStyle/>
                     <a:p>
                       <a:r>
-                        <a:rPr sz="1400" b="0">
+                        <a:rPr sz="1300" b="0">
                           <a:solidFill>
                             <a:srgbClr val="0B0B0B"/>
                           </a:solidFill>
@@ -5796,7 +5796,75 @@
                     <a:lstStyle/>
                     <a:p>
                       <a:r>
-                        <a:rPr sz="1400" b="0">
+                        <a:rPr sz="1300" b="0">
+                          <a:solidFill>
+                            <a:srgbClr val="0B0B0B"/>
+                          </a:solidFill>
+                          <a:latin typeface="Segoe UI"/>
+                        </a:rPr>
+                        <a:t>Join CTD to LISST</a:t>
+                      </a:r>
+                    </a:p>
+                  </a:txBody>
+                  <a:tcPr>
+                    <a:solidFill>
+                      <a:srgbClr val="FCFCFB"/>
+                    </a:solidFill>
+                  </a:tcPr>
+                </a:tc>
+                <a:tc>
+                  <a:txBody>
+                    <a:bodyPr/>
+                    <a:lstStyle/>
+                    <a:p>
+                      <a:r>
+                        <a:rPr sz="1300" b="0">
+                          <a:solidFill>
+                            <a:srgbClr val="0B0B0B"/>
+                          </a:solidFill>
+                          <a:latin typeface="Segoe UI"/>
+                        </a:rPr>
+                        <a:t>Correct the 3–7 s clock offset each day, then match second by second</a:t>
+                      </a:r>
+                    </a:p>
+                  </a:txBody>
+                  <a:tcPr>
+                    <a:solidFill>
+                      <a:srgbClr val="FCFCFB"/>
+                    </a:solidFill>
+                  </a:tcPr>
+                </a:tc>
+                <a:tc>
+                  <a:txBody>
+                    <a:bodyPr/>
+                    <a:lstStyle/>
+                    <a:p>
+                      <a:r>
+                        <a:rPr sz="1300" b="0">
+                          <a:solidFill>
+                            <a:srgbClr val="0B0B0B"/>
+                          </a:solidFill>
+                          <a:latin typeface="Segoe UI"/>
+                        </a:rPr>
+                        <a:t>45,639</a:t>
+                      </a:r>
+                    </a:p>
+                  </a:txBody>
+                  <a:tcPr>
+                    <a:solidFill>
+                      <a:srgbClr val="FCFCFB"/>
+                    </a:solidFill>
+                  </a:tcPr>
+                </a:tc>
+              </a:tr>
+              <a:tr h="384048">
+                <a:tc>
+                  <a:txBody>
+                    <a:bodyPr/>
+                    <a:lstStyle/>
+                    <a:p>
+                      <a:r>
+                        <a:rPr sz="1300" b="0">
                           <a:solidFill>
                             <a:srgbClr val="0B0B0B"/>
                           </a:solidFill>
@@ -5818,13 +5886,13 @@
                     <a:lstStyle/>
                     <a:p>
                       <a:r>
-                        <a:rPr sz="1400" b="0">
+                        <a:rPr sz="1300" b="0">
                           <a:solidFill>
                             <a:srgbClr val="0B0B0B"/>
                           </a:solidFill>
                           <a:latin typeface="Segoe UI"/>
                         </a:rPr>
-                        <a:t>In-air samples, optical transmission outside 30–98 %, depths below the bed</a:t>
+                        <a:t>In-air samples, optical transmission outside 30–98 %, readings with no CTD match</a:t>
                       </a:r>
                     </a:p>
                   </a:txBody>
@@ -5840,13 +5908,13 @@
                     <a:lstStyle/>
                     <a:p>
                       <a:r>
-                        <a:rPr sz="1400" b="0">
+                        <a:rPr sz="1300" b="0">
                           <a:solidFill>
                             <a:srgbClr val="0B0B0B"/>
                           </a:solidFill>
                           <a:latin typeface="Segoe UI"/>
                         </a:rPr>
-                        <a:t>31,896</a:t>
+                        <a:t>33,108</a:t>
                       </a:r>
                     </a:p>
                   </a:txBody>
@@ -5864,7 +5932,7 @@
                     <a:lstStyle/>
                     <a:p>
                       <a:r>
-                        <a:rPr sz="1400" b="0">
+                        <a:rPr sz="1300" b="0">
                           <a:solidFill>
                             <a:srgbClr val="0B0B0B"/>
                           </a:solidFill>
@@ -5886,7 +5954,7 @@
                     <a:lstStyle/>
                     <a:p>
                       <a:r>
-                        <a:rPr sz="1400" b="0">
+                        <a:rPr sz="1300" b="0">
                           <a:solidFill>
                             <a:srgbClr val="0B0B0B"/>
                           </a:solidFill>
@@ -5908,13 +5976,13 @@
                     <a:lstStyle/>
                     <a:p>
                       <a:r>
-                        <a:rPr sz="1400" b="0">
+                        <a:rPr sz="1300" b="0">
                           <a:solidFill>
                             <a:srgbClr val="0B0B0B"/>
                           </a:solidFill>
                           <a:latin typeface="Segoe UI"/>
                         </a:rPr>
-                        <a:t>3,731</a:t>
+                        <a:t>3,998</a:t>
                       </a:r>
                     </a:p>
                   </a:txBody>
@@ -5932,7 +6000,7 @@
                     <a:lstStyle/>
                     <a:p>
                       <a:r>
-                        <a:rPr sz="1400" b="0">
+                        <a:rPr sz="1300" b="0">
                           <a:solidFill>
                             <a:srgbClr val="0B0B0B"/>
                           </a:solidFill>
@@ -5954,13 +6022,13 @@
                     <a:lstStyle/>
                     <a:p>
                       <a:r>
-                        <a:rPr sz="1400" b="0">
+                        <a:rPr sz="1300" b="0">
                           <a:solidFill>
                             <a:srgbClr val="0B0B0B"/>
                           </a:solidFill>
                           <a:latin typeface="Segoe UI"/>
                         </a:rPr>
-                        <a:t>Recompute d50 and σ from each averaged spectrum (r = 0.97 against the file's d50)</a:t>
+                        <a:t>Recompute d50 and σ from each averaged spectrum (r = 0.98 against the file's d50)</a:t>
                       </a:r>
                     </a:p>
                   </a:txBody>
@@ -5976,13 +6044,13 @@
                     <a:lstStyle/>
                     <a:p>
                       <a:r>
-                        <a:rPr sz="1400" b="0">
+                        <a:rPr sz="1300" b="0">
                           <a:solidFill>
                             <a:srgbClr val="0B0B0B"/>
                           </a:solidFill>
                           <a:latin typeface="Segoe UI"/>
                         </a:rPr>
-                        <a:t>3,731</a:t>
+                        <a:t>3,998</a:t>
                       </a:r>
                     </a:p>
                   </a:txBody>
@@ -6005,8 +6073,8 @@
         </p:nvSpPr>
         <p:spPr>
           <a:xfrm>
-            <a:off x="548640" y="4206240"/>
-            <a:ext cx="11064240" cy="2194560"/>
+            <a:off x="548640" y="4343400"/>
+            <a:ext cx="11064240" cy="2103120"/>
           </a:xfrm>
           <a:prstGeom prst="rect">
             <a:avLst/>
@@ -6040,7 +6108,7 @@
                 </a:solidFill>
                 <a:latin typeface="Segoe UI"/>
               </a:rPr>
-              <a:t> 3,731 bursts from 89 casts (50 channel, 39 shallows).</a:t>
+              <a:t> 3,998 bursts from 92 casts (50 channel, 42 shallows).</a:t>
             </a:r>
           </a:p>
           <a:p>
@@ -6056,7 +6124,7 @@
                 </a:solidFill>
                 <a:latin typeface="Segoe UI"/>
               </a:rPr>
-              <a:t>•  Features (7)</a:t>
+              <a:t>•  Features (9)</a:t>
             </a:r>
             <a:r>
               <a:rPr sz="1600" b="0">
@@ -6065,7 +6133,7 @@
                 </a:solidFill>
                 <a:latin typeface="Segoe UI"/>
               </a:rPr>
-              <a:t> Sensor depth, height above bed, water depth (tide stage), tide rate, temperature, beam attenuation, site.</a:t>
+              <a:t> Sensor depth, height above bed, water depth (tide stage), tide rate, temperature, salinity, turbidity, beam attenuation, site.</a:t>
             </a:r>
           </a:p>
           <a:p>
@@ -6384,7 +6452,7 @@
                 </a:solidFill>
                 <a:latin typeface="Segoe UI"/>
               </a:rPr>
-              <a:t>•  SVR sweep on validation casts: C = 0.25, ε = 0.03125</a:t>
+              <a:t>•  SVR sweep on validation casts: C = 0.5, ε = 0.25</a:t>
             </a:r>
           </a:p>
         </p:txBody>
@@ -6783,7 +6851,7 @@
                 </a:solidFill>
                 <a:latin typeface="Segoe UI"/>
               </a:rPr>
-              <a:t>Tide stage, depth and attenuation carry the signal; site adds almost nothing</a:t>
+              <a:t>Depth, tide stage and attenuation carry the signal; salinity matters far less than in the paper</a:t>
             </a:r>
           </a:p>
         </p:txBody>
@@ -6843,8 +6911,8 @@
         </p:blipFill>
         <p:spPr>
           <a:xfrm>
-            <a:off x="1898487" y="1645920"/>
-            <a:ext cx="8364545" cy="3566160"/>
+            <a:off x="2578913" y="1645920"/>
+            <a:ext cx="7003693" cy="3566160"/>
           </a:xfrm>
           <a:prstGeom prst="rect">
             <a:avLst/>
@@ -6885,7 +6953,7 @@
                 </a:solidFill>
                 <a:latin typeface="Segoe UI"/>
               </a:rPr>
-              <a:t>•  Water depth (tide stage) leads for both targets (importance 31 % / 50 % for d50 / σ); salinity played this role in the paper.</a:t>
+              <a:t>•  Sensor depth leads for d50 and water depth for σ. Salinity scores 8 % / 7 % (d50 / σ) against 72 % / 56 % in the paper: over our four days it only varied by about 2 psu.</a:t>
             </a:r>
           </a:p>
           <a:p>
@@ -6901,7 +6969,7 @@
                 </a:solidFill>
                 <a:latin typeface="Segoe UI"/>
               </a:rPr>
-              <a:t>•  Both methods agree on the top four. Permutation importance on unseen casts rates beam attenuation higher and temperature lower than the paper's method does.</a:t>
+              <a:t>•  Permutation importance on unseen casts rates beam attenuation much higher than the paper's method does.</a:t>
             </a:r>
           </a:p>
         </p:txBody>
@@ -7251,7 +7319,7 @@
                 </a:solidFill>
                 <a:latin typeface="Segoe UI"/>
               </a:rPr>
-              <a:t>With the paper's random split we match its result: R² 0.84 and 0.78</a:t>
+              <a:t>With the paper's random split we match its result: R² 0.86 and 0.82</a:t>
             </a:r>
           </a:p>
         </p:txBody>
@@ -7311,8 +7379,8 @@
         </p:blipFill>
         <p:spPr>
           <a:xfrm>
-            <a:off x="832695" y="1554480"/>
-            <a:ext cx="5009729" cy="4937760"/>
+            <a:off x="838953" y="1554480"/>
+            <a:ext cx="4997213" cy="4937760"/>
           </a:xfrm>
           <a:prstGeom prst="rect">
             <a:avLst/>
@@ -7513,7 +7581,7 @@
                           </a:solidFill>
                           <a:latin typeface="Segoe UI"/>
                         </a:rPr>
-                        <a:t>0.84</a:t>
+                        <a:t>0.86</a:t>
                       </a:r>
                     </a:p>
                   </a:txBody>
@@ -7535,7 +7603,7 @@
                           </a:solidFill>
                           <a:latin typeface="Segoe UI"/>
                         </a:rPr>
-                        <a:t>0.78</a:t>
+                        <a:t>0.82</a:t>
                       </a:r>
                     </a:p>
                   </a:txBody>
@@ -7649,7 +7717,7 @@
                           </a:solidFill>
                           <a:latin typeface="Segoe UI"/>
                         </a:rPr>
-                        <a:t>0.64</a:t>
+                        <a:t>0.69</a:t>
                       </a:r>
                     </a:p>
                   </a:txBody>
@@ -7671,7 +7739,7 @@
                           </a:solidFill>
                           <a:latin typeface="Segoe UI"/>
                         </a:rPr>
-                        <a:t>0.64</a:t>
+                        <a:t>0.72</a:t>
                       </a:r>
                     </a:p>
                   </a:txBody>

</xml_diff>